<commit_message>
docs(pitch-decks): add 'Community: Free' row to pricing slides in 15 decks
Added 'Community  Free (Apache 2.0, open-source)' as the first tier row
in all pitch deck slides that contain pricing tier content.

Affected decks: gamma (7), investor-100 (3), investor-50 (2),
investor (1), appendix (1), sales (1)
</commit_message>
<xml_diff>
--- a/docs/pitch-decks/gamma/pptx/01-investor-overview.pptx
+++ b/docs/pitch-decks/gamma/pptx/01-investor-overview.pptx
@@ -7862,6 +7862,24 @@
                   <a:srgbClr val="8B8FA3"/>
                 </a:solidFill>
               </a:rPr>
+              <a:t>Community  Free (Apache 2.0, open-source)</a:t>
+            </a:r>
+            <a:endParaRPr lang="en-US" sz="1200" dirty="0"/>
+          </a:p>
+          <a:p>
+            <a:pPr marL="342900" indent="-342900">
+              <a:lnSpc>
+                <a:spcPct val="150000"/>
+              </a:lnSpc>
+              <a:buSzPct val="100000"/>
+              <a:buChar char="→"/>
+            </a:pPr>
+            <a:r>
+              <a:rPr lang="en-US" sz="1200" dirty="0">
+                <a:solidFill>
+                  <a:srgbClr val="8B8FA3"/>
+                </a:solidFill>
+              </a:rPr>
               <a:t>Gross margin &gt;80%. Net dollar retention &gt;130%. CAC payback &lt;18 months. LTV:CAC &gt;5x. Land with Pilot, expand to Enterprise.</a:t>
             </a:r>
             <a:endParaRPr lang="en-US" sz="1200" dirty="0"/>

</xml_diff>